<commit_message>
Update WoG Orchestration Platform deck
Co-Authored-By: Claude Opus 4.6 (1M context) <noreply@anthropic.com>
</commit_message>
<xml_diff>
--- a/decks/SLG-WoG-Orchestration-Platform.pptx
+++ b/decks/SLG-WoG-Orchestration-Platform.pptx
@@ -947,7 +947,14 @@
           <a:p>
             <a:r>
               <a:rPr lang="en-US" dirty="0"/>
-              <a:t>TIMING ~4 min. Results: 5 life-events live, 179 governance tests green, per-transaction cost falls as agents share the baseline, GovCloud-deployable. Close: the long game — common identity, governed tool access, canonical data, and shared compliance evidence is what turns dozens of demos into digital government.</a:t>
+              <a:t>TIMING ~4 min + close.
+WHAT'S REAL TODAY (read the band as facts, not projections): 5 life-events run end-to-end; 8 governed agents plug in as saga steps with no rewrite; 179 automated governance tests pass with no API key; and ZERO agents can commit a consequential action — a human owns every permit, eligibility decision, records release, and contract award. That last number is the whole pitch in one figure.
+TRADEOFF TALK TRACK — every architecture is a set of bets; here are mine and what they cost:
+(1) SAGA vs. A SINGLE TRANSACTION: there is no two-phase commit across a DMV, an HHS eligibility system, and a 311 CRM — those are separate systems owned by separate agencies. So I use a saga: each step commits, and if a later step fails, the completed steps compensate — roll back — in reverse order. The cost I accept is eventual consistency: a step can briefly succeed before a downstream failure undoes it, which means every step has to be idempotent and reversible. The payoff is that a resident is never left half-enrolled.
+(2) ORCHESTRATOR WITH ZERO TOOL GRANTS vs. SIMPLER WIRING: I could let the orchestrator call agency systems directly and have fewer moving parts. I deliberately don't — it holds no tool grants at all; every write flows through a specialist agent's own deny-by-default gateway. The cost is more indirection. The payoff is blast-radius containment: even if the orchestrator were compromised, it can't exceed any single agent's permissions.
+(3) CONSENT + EXPLICIT CONFIRMATION vs. THROUGHPUT: I gate every material step on recorded consent at the right identity-assurance level AND an explicit resident confirmation, rather than automating silently. The cost is lower end-to-end automation and more round-trips with the resident. I accept it because cross-agency action on someone's identity, benefits, or records is precisely where silent automation is indefensible to an auditor.
+HONEST LIMITATIONS (volunteer them): this is a production-shaped accelerator — the agency integrations run against realistic fixtures and each deployment needs live connectors and a hardening sprint; the life-event set is five today and grows as a data change, not a rebuild.
+CLOSE: the long game is one governed substrate — common identity, governed tool access, canonical data, and shared compliance evidence — and that is what turns dozens of isolated demos into digital government.</a:t>
             </a:r>
             <a:endParaRPr lang="en-US" dirty="0"/>
           </a:p>
@@ -6632,7 +6639,7 @@
                   <a:srgbClr val="CADCFC"/>
                 </a:solidFill>
               </a:rPr>
-              <a:t>MEASURED OUTCOMES — documented results from named deployments &amp; published benchmarks (vendor-reported where noted)</a:t>
+              <a:t>WHAT'S REAL TODAY — runnable, tested, with no API key</a:t>
             </a:r>
             <a:endParaRPr lang="en-US" sz="1200" dirty="0"/>
           </a:p>
@@ -6707,7 +6714,7 @@
                   <a:srgbClr val="CADCFC"/>
                 </a:solidFill>
               </a:rPr>
-              <a:t>life-events live (move · job loss · business · disaster · bereavement)</a:t>
+              <a:t>life-events live: move · job loss · business · disaster · bereavement</a:t>
             </a:r>
             <a:endParaRPr lang="en-US" sz="1150" dirty="0"/>
           </a:p>
@@ -6746,7 +6753,7 @@
                 <a:ea typeface="Cambria" pitchFamily="34" charset="-122"/>
                 <a:cs typeface="Cambria" pitchFamily="34" charset="-120"/>
               </a:rPr>
-              <a:t>179</a:t>
+              <a:t>8</a:t>
             </a:r>
             <a:endParaRPr lang="en-US" sz="3200" dirty="0"/>
           </a:p>
@@ -6782,7 +6789,7 @@
                   <a:srgbClr val="CADCFC"/>
                 </a:solidFill>
               </a:rPr>
-              <a:t>automated governance tests passing, no API key</a:t>
+              <a:t>governed agents plug in as saga steps — no rewrite</a:t>
             </a:r>
             <a:endParaRPr lang="en-US" sz="1150" dirty="0"/>
           </a:p>
@@ -6821,7 +6828,7 @@
                 <a:ea typeface="Cambria" pitchFamily="34" charset="-122"/>
                 <a:cs typeface="Cambria" pitchFamily="34" charset="-120"/>
               </a:rPr>
-              <a:t>falls</a:t>
+              <a:t>179</a:t>
             </a:r>
             <a:endParaRPr lang="en-US" sz="3200" dirty="0"/>
           </a:p>
@@ -6857,7 +6864,7 @@
                   <a:srgbClr val="CADCFC"/>
                 </a:solidFill>
               </a:rPr>
-              <a:t>per-transaction cost as agents share the baseline</a:t>
+              <a:t>automated governance tests pass — no API key</a:t>
             </a:r>
             <a:endParaRPr lang="en-US" sz="1150" dirty="0"/>
           </a:p>
@@ -6896,7 +6903,7 @@
                 <a:ea typeface="Cambria" pitchFamily="34" charset="-122"/>
                 <a:cs typeface="Cambria" pitchFamily="34" charset="-120"/>
               </a:rPr>
-              <a:t>GovCloud</a:t>
+              <a:t>0</a:t>
             </a:r>
             <a:endParaRPr lang="en-US" sz="3200" dirty="0"/>
           </a:p>
@@ -6932,7 +6939,7 @@
                   <a:srgbClr val="CADCFC"/>
                 </a:solidFill>
               </a:rPr>
-              <a:t>deployable in commercial &amp; GovCloud (portable gateway)</a:t>
+              <a:t>agents that can commit a consequential action — a human owns every one</a:t>
             </a:r>
             <a:endParaRPr lang="en-US" sz="1150" dirty="0"/>
           </a:p>
@@ -7037,7 +7044,7 @@
                   <a:srgbClr val="1B2440"/>
                 </a:solidFill>
               </a:rPr>
-              <a:t>Saga (eventual consistency + compensation) over a distributed transaction that can't exist across agencies.</a:t>
+              <a:t>Saga over a single transaction — no two-phase commit exists across a DMV, HHS and 311, so steps commit then roll back on failure. Cost: eventual consistency (every step must be idempotent &amp; reversible).</a:t>
             </a:r>
             <a:endParaRPr lang="en-US" sz="1100" dirty="0"/>
           </a:p>
@@ -7055,7 +7062,7 @@
                   <a:srgbClr val="1B2440"/>
                 </a:solidFill>
               </a:rPr>
-              <a:t>Orchestrator holds no tool grants — authority never concentrates, at the cost of more indirection.</a:t>
+              <a:t>Orchestrator holds zero tool grants — we won't concentrate authority in one place. Cost: more indirection; payoff: a compromise can't exceed any one agent's permissions.</a:t>
             </a:r>
             <a:endParaRPr lang="en-US" sz="1100" dirty="0"/>
           </a:p>
@@ -7073,7 +7080,7 @@
                   <a:srgbClr val="1B2440"/>
                 </a:solidFill>
               </a:rPr>
-              <a:t>Explicit consent + confirmation gates over silent automation — by design.</a:t>
+              <a:t>Consent + explicit confirmation over silent automation — caps end-to-end automation and adds resident round-trips. Accepted: action on identity/benefits/records demands it.</a:t>
             </a:r>
             <a:endParaRPr lang="en-US" sz="1100" dirty="0"/>
           </a:p>

</xml_diff>